<commit_message>
[MOD] Ajustement de la présentation .pptx
</commit_message>
<xml_diff>
--- a/Groupe_D_Presentation.pptx
+++ b/Groupe_D_Presentation.pptx
@@ -6178,13 +6178,426 @@
       </p:sp>
       <p:sp>
         <p:nvSpPr>
-          <p:cNvPr id="9" name="Shape 7"/>
+          <p:cNvPr id="12" name="Shape 10"/>
+          <p:cNvSpPr/>
+          <p:nvPr/>
+        </p:nvSpPr>
+        <p:spPr>
+          <a:xfrm>
+            <a:off x="457200" y="3017520"/>
+            <a:ext cx="2651760" cy="1463040"/>
+          </a:xfrm>
+          <a:prstGeom prst="roundRect">
+            <a:avLst>
+              <a:gd name="adj" fmla="val 6250"/>
+            </a:avLst>
+          </a:prstGeom>
+          <a:solidFill>
+            <a:srgbClr val="F8D7DA"/>
+          </a:solidFill>
+          <a:ln w="12700">
+            <a:solidFill>
+              <a:srgbClr val="1E3A5F"/>
+            </a:solidFill>
+            <a:prstDash val="solid"/>
+          </a:ln>
+          <a:effectLst>
+            <a:outerShdw blurRad="63500" dist="25400" dir="2700000" algn="bl" rotWithShape="0">
+              <a:srgbClr val="000000">
+                <a:alpha val="10000"/>
+              </a:srgbClr>
+            </a:outerShdw>
+          </a:effectLst>
+        </p:spPr>
+        <p:txBody>
+          <a:bodyPr/>
+          <a:lstStyle/>
+          <a:p>
+            <a:endParaRPr lang="fr-FR"/>
+          </a:p>
+        </p:txBody>
+      </p:sp>
+      <p:sp>
+        <p:nvSpPr>
+          <p:cNvPr id="13" name="Text 11"/>
+          <p:cNvSpPr/>
+          <p:nvPr/>
+        </p:nvSpPr>
+        <p:spPr>
+          <a:xfrm>
+            <a:off x="548640" y="3108960"/>
+            <a:ext cx="2468880" cy="457200"/>
+          </a:xfrm>
+          <a:prstGeom prst="rect">
+            <a:avLst/>
+          </a:prstGeom>
+          <a:noFill/>
+          <a:ln/>
+        </p:spPr>
+        <p:txBody>
+          <a:bodyPr wrap="square" lIns="0" tIns="0" rIns="0" bIns="0" rtlCol="0" anchor="ctr"/>
+          <a:lstStyle/>
+          <a:p>
+            <a:pPr marL="0" indent="0" algn="ctr">
+              <a:buNone/>
+            </a:pPr>
+            <a:r>
+              <a:rPr lang="en-US" sz="1800" b="1" dirty="0">
+                <a:solidFill>
+                  <a:srgbClr val="1E3A5F"/>
+                </a:solidFill>
+                <a:latin typeface="Calibri" pitchFamily="34" charset="0"/>
+                <a:ea typeface="Calibri" pitchFamily="34" charset="-122"/>
+                <a:cs typeface="Calibri" pitchFamily="34" charset="-120"/>
+              </a:rPr>
+              <a:t>NumPy</a:t>
+            </a:r>
+            <a:endParaRPr lang="en-US" sz="1800" dirty="0"/>
+          </a:p>
+        </p:txBody>
+      </p:sp>
+      <p:sp>
+        <p:nvSpPr>
+          <p:cNvPr id="14" name="Text 12"/>
+          <p:cNvSpPr/>
+          <p:nvPr/>
+        </p:nvSpPr>
+        <p:spPr>
+          <a:xfrm>
+            <a:off x="548640" y="3611880"/>
+            <a:ext cx="2468880" cy="731520"/>
+          </a:xfrm>
+          <a:prstGeom prst="rect">
+            <a:avLst/>
+          </a:prstGeom>
+          <a:noFill/>
+          <a:ln/>
+        </p:spPr>
+        <p:txBody>
+          <a:bodyPr wrap="square" lIns="0" tIns="0" rIns="0" bIns="0" rtlCol="0" anchor="ctr"/>
+          <a:lstStyle/>
+          <a:p>
+            <a:pPr marL="0" indent="0" algn="ctr">
+              <a:buNone/>
+            </a:pPr>
+            <a:r>
+              <a:rPr lang="en-US" sz="1200" dirty="0">
+                <a:solidFill>
+                  <a:srgbClr val="555555"/>
+                </a:solidFill>
+                <a:latin typeface="Calibri" pitchFamily="34" charset="0"/>
+                <a:ea typeface="Calibri" pitchFamily="34" charset="-122"/>
+                <a:cs typeface="Calibri" pitchFamily="34" charset="-120"/>
+              </a:rPr>
+              <a:t>Calculs numériques</a:t>
+            </a:r>
+            <a:endParaRPr lang="en-US" sz="1200" dirty="0"/>
+          </a:p>
+          <a:p>
+            <a:pPr marL="0" indent="0" algn="ctr">
+              <a:buNone/>
+            </a:pPr>
+            <a:r>
+              <a:rPr lang="en-US" sz="1200" dirty="0">
+                <a:solidFill>
+                  <a:srgbClr val="555555"/>
+                </a:solidFill>
+                <a:latin typeface="Calibri" pitchFamily="34" charset="0"/>
+                <a:ea typeface="Calibri" pitchFamily="34" charset="-122"/>
+                <a:cs typeface="Calibri" pitchFamily="34" charset="-120"/>
+              </a:rPr>
+              <a:t>sur les features</a:t>
+            </a:r>
+            <a:endParaRPr lang="en-US" sz="1200" dirty="0"/>
+          </a:p>
+        </p:txBody>
+      </p:sp>
+      <p:sp>
+        <p:nvSpPr>
+          <p:cNvPr id="15" name="Shape 13"/>
+          <p:cNvSpPr/>
+          <p:nvPr/>
+        </p:nvSpPr>
+        <p:spPr>
+          <a:xfrm>
+            <a:off x="3337560" y="3017520"/>
+            <a:ext cx="2651760" cy="1463040"/>
+          </a:xfrm>
+          <a:prstGeom prst="roundRect">
+            <a:avLst>
+              <a:gd name="adj" fmla="val 6250"/>
+            </a:avLst>
+          </a:prstGeom>
+          <a:solidFill>
+            <a:srgbClr val="E2D9F3"/>
+          </a:solidFill>
+          <a:ln w="12700">
+            <a:solidFill>
+              <a:srgbClr val="1E3A5F"/>
+            </a:solidFill>
+            <a:prstDash val="solid"/>
+          </a:ln>
+          <a:effectLst>
+            <a:outerShdw blurRad="63500" dist="25400" dir="2700000" algn="bl" rotWithShape="0">
+              <a:srgbClr val="000000">
+                <a:alpha val="10000"/>
+              </a:srgbClr>
+            </a:outerShdw>
+          </a:effectLst>
+        </p:spPr>
+        <p:txBody>
+          <a:bodyPr/>
+          <a:lstStyle/>
+          <a:p>
+            <a:endParaRPr lang="fr-FR"/>
+          </a:p>
+        </p:txBody>
+      </p:sp>
+      <p:sp>
+        <p:nvSpPr>
+          <p:cNvPr id="16" name="Text 14"/>
+          <p:cNvSpPr/>
+          <p:nvPr/>
+        </p:nvSpPr>
+        <p:spPr>
+          <a:xfrm>
+            <a:off x="3429000" y="3108960"/>
+            <a:ext cx="2468880" cy="457200"/>
+          </a:xfrm>
+          <a:prstGeom prst="rect">
+            <a:avLst/>
+          </a:prstGeom>
+          <a:noFill/>
+          <a:ln/>
+        </p:spPr>
+        <p:txBody>
+          <a:bodyPr wrap="square" lIns="0" tIns="0" rIns="0" bIns="0" rtlCol="0" anchor="ctr"/>
+          <a:lstStyle/>
+          <a:p>
+            <a:pPr marL="0" indent="0" algn="ctr">
+              <a:buNone/>
+            </a:pPr>
+            <a:r>
+              <a:rPr lang="en-US" sz="1800" b="1" dirty="0">
+                <a:solidFill>
+                  <a:srgbClr val="1E3A5F"/>
+                </a:solidFill>
+                <a:latin typeface="Calibri" pitchFamily="34" charset="0"/>
+                <a:ea typeface="Calibri" pitchFamily="34" charset="-122"/>
+                <a:cs typeface="Calibri" pitchFamily="34" charset="-120"/>
+              </a:rPr>
+              <a:t>Git</a:t>
+            </a:r>
+            <a:endParaRPr lang="en-US" sz="1800" dirty="0"/>
+          </a:p>
+        </p:txBody>
+      </p:sp>
+      <p:sp>
+        <p:nvSpPr>
+          <p:cNvPr id="17" name="Text 15"/>
+          <p:cNvSpPr/>
+          <p:nvPr/>
+        </p:nvSpPr>
+        <p:spPr>
+          <a:xfrm>
+            <a:off x="3429000" y="3611880"/>
+            <a:ext cx="2468880" cy="731520"/>
+          </a:xfrm>
+          <a:prstGeom prst="rect">
+            <a:avLst/>
+          </a:prstGeom>
+          <a:noFill/>
+          <a:ln/>
+        </p:spPr>
+        <p:txBody>
+          <a:bodyPr wrap="square" lIns="0" tIns="0" rIns="0" bIns="0" rtlCol="0" anchor="ctr"/>
+          <a:lstStyle/>
+          <a:p>
+            <a:pPr marL="0" indent="0" algn="ctr">
+              <a:buNone/>
+            </a:pPr>
+            <a:r>
+              <a:rPr lang="en-US" sz="1200" dirty="0">
+                <a:solidFill>
+                  <a:srgbClr val="555555"/>
+                </a:solidFill>
+                <a:latin typeface="Calibri" pitchFamily="34" charset="0"/>
+                <a:ea typeface="Calibri" pitchFamily="34" charset="-122"/>
+                <a:cs typeface="Calibri" pitchFamily="34" charset="-120"/>
+              </a:rPr>
+              <a:t>Versioning</a:t>
+            </a:r>
+            <a:endParaRPr lang="en-US" sz="1200" dirty="0"/>
+          </a:p>
+          <a:p>
+            <a:pPr marL="0" indent="0" algn="ctr">
+              <a:buNone/>
+            </a:pPr>
+            <a:r>
+              <a:rPr lang="en-US" sz="1200" dirty="0">
+                <a:solidFill>
+                  <a:srgbClr val="555555"/>
+                </a:solidFill>
+                <a:latin typeface="Calibri" pitchFamily="34" charset="0"/>
+                <a:ea typeface="Calibri" pitchFamily="34" charset="-122"/>
+                <a:cs typeface="Calibri" pitchFamily="34" charset="-120"/>
+              </a:rPr>
+              <a:t>branche group-D</a:t>
+            </a:r>
+            <a:endParaRPr lang="en-US" sz="1200" dirty="0"/>
+          </a:p>
+        </p:txBody>
+      </p:sp>
+      <p:sp>
+        <p:nvSpPr>
+          <p:cNvPr id="18" name="Shape 16"/>
           <p:cNvSpPr/>
           <p:nvPr/>
         </p:nvSpPr>
         <p:spPr>
           <a:xfrm>
             <a:off x="6217920" y="1188720"/>
+            <a:ext cx="2651760" cy="1463040"/>
+          </a:xfrm>
+          <a:prstGeom prst="roundRect">
+            <a:avLst>
+              <a:gd name="adj" fmla="val 6250"/>
+            </a:avLst>
+          </a:prstGeom>
+          <a:solidFill>
+            <a:srgbClr val="FFE5D0"/>
+          </a:solidFill>
+          <a:ln w="12700">
+            <a:solidFill>
+              <a:srgbClr val="1E3A5F"/>
+            </a:solidFill>
+            <a:prstDash val="solid"/>
+          </a:ln>
+          <a:effectLst>
+            <a:outerShdw blurRad="63500" dist="25400" dir="2700000" algn="bl" rotWithShape="0">
+              <a:srgbClr val="000000">
+                <a:alpha val="10000"/>
+              </a:srgbClr>
+            </a:outerShdw>
+          </a:effectLst>
+        </p:spPr>
+        <p:txBody>
+          <a:bodyPr/>
+          <a:lstStyle/>
+          <a:p>
+            <a:endParaRPr lang="fr-FR"/>
+          </a:p>
+        </p:txBody>
+      </p:sp>
+      <p:sp>
+        <p:nvSpPr>
+          <p:cNvPr id="19" name="Text 17"/>
+          <p:cNvSpPr/>
+          <p:nvPr/>
+        </p:nvSpPr>
+        <p:spPr>
+          <a:xfrm>
+            <a:off x="6309360" y="1280160"/>
+            <a:ext cx="2468880" cy="457200"/>
+          </a:xfrm>
+          <a:prstGeom prst="rect">
+            <a:avLst/>
+          </a:prstGeom>
+          <a:noFill/>
+          <a:ln/>
+        </p:spPr>
+        <p:txBody>
+          <a:bodyPr wrap="square" lIns="0" tIns="0" rIns="0" bIns="0" rtlCol="0" anchor="ctr"/>
+          <a:lstStyle/>
+          <a:p>
+            <a:pPr marL="0" indent="0" algn="ctr">
+              <a:buNone/>
+            </a:pPr>
+            <a:r>
+              <a:rPr lang="en-US" sz="1800" b="1" dirty="0" err="1">
+                <a:solidFill>
+                  <a:srgbClr val="1E3A5F"/>
+                </a:solidFill>
+                <a:latin typeface="Calibri" pitchFamily="34" charset="0"/>
+                <a:ea typeface="Calibri" pitchFamily="34" charset="-122"/>
+                <a:cs typeface="Calibri" pitchFamily="34" charset="-120"/>
+              </a:rPr>
+              <a:t>Sklearn</a:t>
+            </a:r>
+            <a:endParaRPr lang="en-US" sz="1800" dirty="0"/>
+          </a:p>
+        </p:txBody>
+      </p:sp>
+      <p:sp>
+        <p:nvSpPr>
+          <p:cNvPr id="20" name="Text 18"/>
+          <p:cNvSpPr/>
+          <p:nvPr/>
+        </p:nvSpPr>
+        <p:spPr>
+          <a:xfrm>
+            <a:off x="6309360" y="1783080"/>
+            <a:ext cx="2468880" cy="731520"/>
+          </a:xfrm>
+          <a:prstGeom prst="rect">
+            <a:avLst/>
+          </a:prstGeom>
+          <a:noFill/>
+          <a:ln/>
+        </p:spPr>
+        <p:txBody>
+          <a:bodyPr wrap="square" lIns="0" tIns="0" rIns="0" bIns="0" rtlCol="0" anchor="ctr"/>
+          <a:lstStyle/>
+          <a:p>
+            <a:pPr marL="0" indent="0" algn="ctr">
+              <a:buNone/>
+            </a:pPr>
+            <a:r>
+              <a:rPr lang="en-US" sz="1200" dirty="0">
+                <a:solidFill>
+                  <a:srgbClr val="555555"/>
+                </a:solidFill>
+                <a:latin typeface="Calibri" pitchFamily="34" charset="0"/>
+                <a:ea typeface="Calibri" pitchFamily="34" charset="-122"/>
+                <a:cs typeface="Calibri" pitchFamily="34" charset="-120"/>
+              </a:rPr>
+              <a:t>Creation du </a:t>
+            </a:r>
+            <a:r>
+              <a:rPr lang="en-US" sz="1200" dirty="0" err="1">
+                <a:solidFill>
+                  <a:srgbClr val="555555"/>
+                </a:solidFill>
+                <a:latin typeface="Calibri" pitchFamily="34" charset="0"/>
+                <a:ea typeface="Calibri" pitchFamily="34" charset="-122"/>
+                <a:cs typeface="Calibri" pitchFamily="34" charset="-120"/>
+              </a:rPr>
+              <a:t>modèle</a:t>
+            </a:r>
+            <a:r>
+              <a:rPr lang="en-US" sz="1200" dirty="0">
+                <a:solidFill>
+                  <a:srgbClr val="555555"/>
+                </a:solidFill>
+                <a:latin typeface="Calibri" pitchFamily="34" charset="0"/>
+                <a:ea typeface="Calibri" pitchFamily="34" charset="-122"/>
+                <a:cs typeface="Calibri" pitchFamily="34" charset="-120"/>
+              </a:rPr>
+              <a:t>/machine learning</a:t>
+            </a:r>
+            <a:endParaRPr lang="en-US" sz="1200" dirty="0"/>
+          </a:p>
+        </p:txBody>
+      </p:sp>
+      <p:sp>
+        <p:nvSpPr>
+          <p:cNvPr id="21" name="Shape 7"/>
+          <p:cNvSpPr/>
+          <p:nvPr/>
+        </p:nvSpPr>
+        <p:spPr>
+          <a:xfrm>
+            <a:off x="6217920" y="3017520"/>
             <a:ext cx="2651760" cy="1463040"/>
           </a:xfrm>
           <a:prstGeom prst="roundRect">
@@ -6219,13 +6632,13 @@
       </p:sp>
       <p:sp>
         <p:nvSpPr>
-          <p:cNvPr id="10" name="Text 8"/>
-          <p:cNvSpPr/>
-          <p:nvPr/>
-        </p:nvSpPr>
-        <p:spPr>
-          <a:xfrm>
-            <a:off x="6309360" y="1280160"/>
+          <p:cNvPr id="22" name="Text 8"/>
+          <p:cNvSpPr/>
+          <p:nvPr/>
+        </p:nvSpPr>
+        <p:spPr>
+          <a:xfrm>
+            <a:off x="6309360" y="3108960"/>
             <a:ext cx="2468880" cy="457200"/>
           </a:xfrm>
           <a:prstGeom prst="rect">
@@ -6258,13 +6671,13 @@
       </p:sp>
       <p:sp>
         <p:nvSpPr>
-          <p:cNvPr id="11" name="Text 9"/>
-          <p:cNvSpPr/>
-          <p:nvPr/>
-        </p:nvSpPr>
-        <p:spPr>
-          <a:xfrm>
-            <a:off x="6309360" y="1783080"/>
+          <p:cNvPr id="23" name="Text 9"/>
+          <p:cNvSpPr/>
+          <p:nvPr/>
+        </p:nvSpPr>
+        <p:spPr>
+          <a:xfrm>
+            <a:off x="6309360" y="3611880"/>
             <a:ext cx="2468880" cy="731520"/>
           </a:xfrm>
           <a:prstGeom prst="rect">
@@ -6307,414 +6720,6 @@
                 <a:cs typeface="Calibri" pitchFamily="34" charset="-120"/>
               </a:rPr>
               <a:t>des fichiers CSV</a:t>
-            </a:r>
-            <a:endParaRPr lang="en-US" sz="1200" dirty="0"/>
-          </a:p>
-        </p:txBody>
-      </p:sp>
-      <p:sp>
-        <p:nvSpPr>
-          <p:cNvPr id="12" name="Shape 10"/>
-          <p:cNvSpPr/>
-          <p:nvPr/>
-        </p:nvSpPr>
-        <p:spPr>
-          <a:xfrm>
-            <a:off x="457200" y="3017520"/>
-            <a:ext cx="2651760" cy="1463040"/>
-          </a:xfrm>
-          <a:prstGeom prst="roundRect">
-            <a:avLst>
-              <a:gd name="adj" fmla="val 6250"/>
-            </a:avLst>
-          </a:prstGeom>
-          <a:solidFill>
-            <a:srgbClr val="F8D7DA"/>
-          </a:solidFill>
-          <a:ln w="12700">
-            <a:solidFill>
-              <a:srgbClr val="1E3A5F"/>
-            </a:solidFill>
-            <a:prstDash val="solid"/>
-          </a:ln>
-          <a:effectLst>
-            <a:outerShdw blurRad="63500" dist="25400" dir="2700000" algn="bl" rotWithShape="0">
-              <a:srgbClr val="000000">
-                <a:alpha val="10000"/>
-              </a:srgbClr>
-            </a:outerShdw>
-          </a:effectLst>
-        </p:spPr>
-        <p:txBody>
-          <a:bodyPr/>
-          <a:lstStyle/>
-          <a:p>
-            <a:endParaRPr lang="fr-FR"/>
-          </a:p>
-        </p:txBody>
-      </p:sp>
-      <p:sp>
-        <p:nvSpPr>
-          <p:cNvPr id="13" name="Text 11"/>
-          <p:cNvSpPr/>
-          <p:nvPr/>
-        </p:nvSpPr>
-        <p:spPr>
-          <a:xfrm>
-            <a:off x="548640" y="3108960"/>
-            <a:ext cx="2468880" cy="457200"/>
-          </a:xfrm>
-          <a:prstGeom prst="rect">
-            <a:avLst/>
-          </a:prstGeom>
-          <a:noFill/>
-          <a:ln/>
-        </p:spPr>
-        <p:txBody>
-          <a:bodyPr wrap="square" lIns="0" tIns="0" rIns="0" bIns="0" rtlCol="0" anchor="ctr"/>
-          <a:lstStyle/>
-          <a:p>
-            <a:pPr marL="0" indent="0" algn="ctr">
-              <a:buNone/>
-            </a:pPr>
-            <a:r>
-              <a:rPr lang="en-US" sz="1800" b="1" dirty="0">
-                <a:solidFill>
-                  <a:srgbClr val="1E3A5F"/>
-                </a:solidFill>
-                <a:latin typeface="Calibri" pitchFamily="34" charset="0"/>
-                <a:ea typeface="Calibri" pitchFamily="34" charset="-122"/>
-                <a:cs typeface="Calibri" pitchFamily="34" charset="-120"/>
-              </a:rPr>
-              <a:t>NumPy</a:t>
-            </a:r>
-            <a:endParaRPr lang="en-US" sz="1800" dirty="0"/>
-          </a:p>
-        </p:txBody>
-      </p:sp>
-      <p:sp>
-        <p:nvSpPr>
-          <p:cNvPr id="14" name="Text 12"/>
-          <p:cNvSpPr/>
-          <p:nvPr/>
-        </p:nvSpPr>
-        <p:spPr>
-          <a:xfrm>
-            <a:off x="548640" y="3611880"/>
-            <a:ext cx="2468880" cy="731520"/>
-          </a:xfrm>
-          <a:prstGeom prst="rect">
-            <a:avLst/>
-          </a:prstGeom>
-          <a:noFill/>
-          <a:ln/>
-        </p:spPr>
-        <p:txBody>
-          <a:bodyPr wrap="square" lIns="0" tIns="0" rIns="0" bIns="0" rtlCol="0" anchor="ctr"/>
-          <a:lstStyle/>
-          <a:p>
-            <a:pPr marL="0" indent="0" algn="ctr">
-              <a:buNone/>
-            </a:pPr>
-            <a:r>
-              <a:rPr lang="en-US" sz="1200" dirty="0">
-                <a:solidFill>
-                  <a:srgbClr val="555555"/>
-                </a:solidFill>
-                <a:latin typeface="Calibri" pitchFamily="34" charset="0"/>
-                <a:ea typeface="Calibri" pitchFamily="34" charset="-122"/>
-                <a:cs typeface="Calibri" pitchFamily="34" charset="-120"/>
-              </a:rPr>
-              <a:t>Calculs numériques</a:t>
-            </a:r>
-            <a:endParaRPr lang="en-US" sz="1200" dirty="0"/>
-          </a:p>
-          <a:p>
-            <a:pPr marL="0" indent="0" algn="ctr">
-              <a:buNone/>
-            </a:pPr>
-            <a:r>
-              <a:rPr lang="en-US" sz="1200" dirty="0">
-                <a:solidFill>
-                  <a:srgbClr val="555555"/>
-                </a:solidFill>
-                <a:latin typeface="Calibri" pitchFamily="34" charset="0"/>
-                <a:ea typeface="Calibri" pitchFamily="34" charset="-122"/>
-                <a:cs typeface="Calibri" pitchFamily="34" charset="-120"/>
-              </a:rPr>
-              <a:t>sur les features</a:t>
-            </a:r>
-            <a:endParaRPr lang="en-US" sz="1200" dirty="0"/>
-          </a:p>
-        </p:txBody>
-      </p:sp>
-      <p:sp>
-        <p:nvSpPr>
-          <p:cNvPr id="15" name="Shape 13"/>
-          <p:cNvSpPr/>
-          <p:nvPr/>
-        </p:nvSpPr>
-        <p:spPr>
-          <a:xfrm>
-            <a:off x="3337560" y="3017520"/>
-            <a:ext cx="2651760" cy="1463040"/>
-          </a:xfrm>
-          <a:prstGeom prst="roundRect">
-            <a:avLst>
-              <a:gd name="adj" fmla="val 6250"/>
-            </a:avLst>
-          </a:prstGeom>
-          <a:solidFill>
-            <a:srgbClr val="E2D9F3"/>
-          </a:solidFill>
-          <a:ln w="12700">
-            <a:solidFill>
-              <a:srgbClr val="1E3A5F"/>
-            </a:solidFill>
-            <a:prstDash val="solid"/>
-          </a:ln>
-          <a:effectLst>
-            <a:outerShdw blurRad="63500" dist="25400" dir="2700000" algn="bl" rotWithShape="0">
-              <a:srgbClr val="000000">
-                <a:alpha val="10000"/>
-              </a:srgbClr>
-            </a:outerShdw>
-          </a:effectLst>
-        </p:spPr>
-        <p:txBody>
-          <a:bodyPr/>
-          <a:lstStyle/>
-          <a:p>
-            <a:endParaRPr lang="fr-FR"/>
-          </a:p>
-        </p:txBody>
-      </p:sp>
-      <p:sp>
-        <p:nvSpPr>
-          <p:cNvPr id="16" name="Text 14"/>
-          <p:cNvSpPr/>
-          <p:nvPr/>
-        </p:nvSpPr>
-        <p:spPr>
-          <a:xfrm>
-            <a:off x="3429000" y="3108960"/>
-            <a:ext cx="2468880" cy="457200"/>
-          </a:xfrm>
-          <a:prstGeom prst="rect">
-            <a:avLst/>
-          </a:prstGeom>
-          <a:noFill/>
-          <a:ln/>
-        </p:spPr>
-        <p:txBody>
-          <a:bodyPr wrap="square" lIns="0" tIns="0" rIns="0" bIns="0" rtlCol="0" anchor="ctr"/>
-          <a:lstStyle/>
-          <a:p>
-            <a:pPr marL="0" indent="0" algn="ctr">
-              <a:buNone/>
-            </a:pPr>
-            <a:r>
-              <a:rPr lang="en-US" sz="1800" b="1" dirty="0">
-                <a:solidFill>
-                  <a:srgbClr val="1E3A5F"/>
-                </a:solidFill>
-                <a:latin typeface="Calibri" pitchFamily="34" charset="0"/>
-                <a:ea typeface="Calibri" pitchFamily="34" charset="-122"/>
-                <a:cs typeface="Calibri" pitchFamily="34" charset="-120"/>
-              </a:rPr>
-              <a:t>Git</a:t>
-            </a:r>
-            <a:endParaRPr lang="en-US" sz="1800" dirty="0"/>
-          </a:p>
-        </p:txBody>
-      </p:sp>
-      <p:sp>
-        <p:nvSpPr>
-          <p:cNvPr id="17" name="Text 15"/>
-          <p:cNvSpPr/>
-          <p:nvPr/>
-        </p:nvSpPr>
-        <p:spPr>
-          <a:xfrm>
-            <a:off x="3429000" y="3611880"/>
-            <a:ext cx="2468880" cy="731520"/>
-          </a:xfrm>
-          <a:prstGeom prst="rect">
-            <a:avLst/>
-          </a:prstGeom>
-          <a:noFill/>
-          <a:ln/>
-        </p:spPr>
-        <p:txBody>
-          <a:bodyPr wrap="square" lIns="0" tIns="0" rIns="0" bIns="0" rtlCol="0" anchor="ctr"/>
-          <a:lstStyle/>
-          <a:p>
-            <a:pPr marL="0" indent="0" algn="ctr">
-              <a:buNone/>
-            </a:pPr>
-            <a:r>
-              <a:rPr lang="en-US" sz="1200" dirty="0">
-                <a:solidFill>
-                  <a:srgbClr val="555555"/>
-                </a:solidFill>
-                <a:latin typeface="Calibri" pitchFamily="34" charset="0"/>
-                <a:ea typeface="Calibri" pitchFamily="34" charset="-122"/>
-                <a:cs typeface="Calibri" pitchFamily="34" charset="-120"/>
-              </a:rPr>
-              <a:t>Versioning</a:t>
-            </a:r>
-            <a:endParaRPr lang="en-US" sz="1200" dirty="0"/>
-          </a:p>
-          <a:p>
-            <a:pPr marL="0" indent="0" algn="ctr">
-              <a:buNone/>
-            </a:pPr>
-            <a:r>
-              <a:rPr lang="en-US" sz="1200" dirty="0">
-                <a:solidFill>
-                  <a:srgbClr val="555555"/>
-                </a:solidFill>
-                <a:latin typeface="Calibri" pitchFamily="34" charset="0"/>
-                <a:ea typeface="Calibri" pitchFamily="34" charset="-122"/>
-                <a:cs typeface="Calibri" pitchFamily="34" charset="-120"/>
-              </a:rPr>
-              <a:t>branche group-D</a:t>
-            </a:r>
-            <a:endParaRPr lang="en-US" sz="1200" dirty="0"/>
-          </a:p>
-        </p:txBody>
-      </p:sp>
-      <p:sp>
-        <p:nvSpPr>
-          <p:cNvPr id="18" name="Shape 16"/>
-          <p:cNvSpPr/>
-          <p:nvPr/>
-        </p:nvSpPr>
-        <p:spPr>
-          <a:xfrm>
-            <a:off x="6217920" y="3017520"/>
-            <a:ext cx="2651760" cy="1463040"/>
-          </a:xfrm>
-          <a:prstGeom prst="roundRect">
-            <a:avLst>
-              <a:gd name="adj" fmla="val 6250"/>
-            </a:avLst>
-          </a:prstGeom>
-          <a:solidFill>
-            <a:srgbClr val="FFE5D0"/>
-          </a:solidFill>
-          <a:ln w="12700">
-            <a:solidFill>
-              <a:srgbClr val="1E3A5F"/>
-            </a:solidFill>
-            <a:prstDash val="solid"/>
-          </a:ln>
-          <a:effectLst>
-            <a:outerShdw blurRad="63500" dist="25400" dir="2700000" algn="bl" rotWithShape="0">
-              <a:srgbClr val="000000">
-                <a:alpha val="10000"/>
-              </a:srgbClr>
-            </a:outerShdw>
-          </a:effectLst>
-        </p:spPr>
-        <p:txBody>
-          <a:bodyPr/>
-          <a:lstStyle/>
-          <a:p>
-            <a:endParaRPr lang="fr-FR"/>
-          </a:p>
-        </p:txBody>
-      </p:sp>
-      <p:sp>
-        <p:nvSpPr>
-          <p:cNvPr id="19" name="Text 17"/>
-          <p:cNvSpPr/>
-          <p:nvPr/>
-        </p:nvSpPr>
-        <p:spPr>
-          <a:xfrm>
-            <a:off x="6309360" y="3108960"/>
-            <a:ext cx="2468880" cy="457200"/>
-          </a:xfrm>
-          <a:prstGeom prst="rect">
-            <a:avLst/>
-          </a:prstGeom>
-          <a:noFill/>
-          <a:ln/>
-        </p:spPr>
-        <p:txBody>
-          <a:bodyPr wrap="square" lIns="0" tIns="0" rIns="0" bIns="0" rtlCol="0" anchor="ctr"/>
-          <a:lstStyle/>
-          <a:p>
-            <a:pPr marL="0" indent="0" algn="ctr">
-              <a:buNone/>
-            </a:pPr>
-            <a:r>
-              <a:rPr lang="en-US" sz="1800" b="1" dirty="0">
-                <a:solidFill>
-                  <a:srgbClr val="1E3A5F"/>
-                </a:solidFill>
-                <a:latin typeface="Calibri" pitchFamily="34" charset="0"/>
-                <a:ea typeface="Calibri" pitchFamily="34" charset="-122"/>
-                <a:cs typeface="Calibri" pitchFamily="34" charset="-120"/>
-              </a:rPr>
-              <a:t>Scipy</a:t>
-            </a:r>
-            <a:endParaRPr lang="en-US" sz="1800" dirty="0"/>
-          </a:p>
-        </p:txBody>
-      </p:sp>
-      <p:sp>
-        <p:nvSpPr>
-          <p:cNvPr id="20" name="Text 18"/>
-          <p:cNvSpPr/>
-          <p:nvPr/>
-        </p:nvSpPr>
-        <p:spPr>
-          <a:xfrm>
-            <a:off x="6309360" y="3611880"/>
-            <a:ext cx="2468880" cy="731520"/>
-          </a:xfrm>
-          <a:prstGeom prst="rect">
-            <a:avLst/>
-          </a:prstGeom>
-          <a:noFill/>
-          <a:ln/>
-        </p:spPr>
-        <p:txBody>
-          <a:bodyPr wrap="square" lIns="0" tIns="0" rIns="0" bIns="0" rtlCol="0" anchor="ctr"/>
-          <a:lstStyle/>
-          <a:p>
-            <a:pPr marL="0" indent="0" algn="ctr">
-              <a:buNone/>
-            </a:pPr>
-            <a:r>
-              <a:rPr lang="en-US" sz="1200" dirty="0">
-                <a:solidFill>
-                  <a:srgbClr val="555555"/>
-                </a:solidFill>
-                <a:latin typeface="Calibri" pitchFamily="34" charset="0"/>
-                <a:ea typeface="Calibri" pitchFamily="34" charset="-122"/>
-                <a:cs typeface="Calibri" pitchFamily="34" charset="-120"/>
-              </a:rPr>
-              <a:t>Normalisation</a:t>
-            </a:r>
-            <a:endParaRPr lang="en-US" sz="1200" dirty="0"/>
-          </a:p>
-          <a:p>
-            <a:pPr marL="0" indent="0" algn="ctr">
-              <a:buNone/>
-            </a:pPr>
-            <a:r>
-              <a:rPr lang="en-US" sz="1200" dirty="0">
-                <a:solidFill>
-                  <a:srgbClr val="555555"/>
-                </a:solidFill>
-                <a:latin typeface="Calibri" pitchFamily="34" charset="0"/>
-                <a:ea typeface="Calibri" pitchFamily="34" charset="-122"/>
-                <a:cs typeface="Calibri" pitchFamily="34" charset="-120"/>
-              </a:rPr>
-              <a:t>des données</a:t>
             </a:r>
             <a:endParaRPr lang="en-US" sz="1200" dirty="0"/>
           </a:p>

</xml_diff>